<commit_message>
docs: actualiza la diapositiva de monitoreo de la presentación
</commit_message>
<xml_diff>
--- a/Fase 2/Evidencias Proyecto/Presentación Proyecto.pptx
+++ b/Fase 2/Evidencias Proyecto/Presentación Proyecto.pptx
@@ -490,12 +490,12 @@
           </a:p>
           <a:p>
             <a:r>
-              <a:t>Tiempo: 45 segundos.</a:t>
-            </a:r>
-          </a:p>
-          <a:p>
-            <a:r>
-              <a:t>En el monitoreo, el Sprint 1 cerró con 3 de 71 horas en Listo, un 4 %, porque los PR estaban esperando revisión. En el Sprint 2 nos dedicamos a revisar esos PR y fusionamos el 7, pero el contrato HU-03 sigue pendiente. Las dificultades fueron la coordinación del equipo, una capacidad real menor a la planificada, el plazo adelantado al 08-11 y el contrato de Identidad sin escribir.</a:t>
+              <a:t>Tiempo: 55 segundos.</a:t>
+            </a:r>
+          </a:p>
+          <a:p>
+            <a:r>
+              <a:t>En el monitoreo: el objetivo del Sprint 1 funciona, pero todavía no está en develop. En la rama de la demo, que reúne los PR 5 a 12, el registro, la verificación y el inicio de sesión funcionan desde el 02-10. Para que esas historias cuenten como Listo faltan su revisión y su fusión a develop y, en el registro y el inicio de sesión, el contrato HU-03. Por eso, en Listo, el Sprint 1 cerró con 3 de 71 horas, un 4 %. La primera semana del Sprint 2 la usamos para revisar esos PR: Damaris revisó y probó cuatro, y el 7 ya está en develop. Las dificultades fueron la coordinación del equipo, una capacidad real menor a la planificada, el plazo adelantado al 08-11 y el contrato de Identidad sin escribir.</a:t>
             </a:r>
           </a:p>
         </p:txBody>
@@ -12770,7 +12770,7 @@
                 <a:ea typeface="Calibri" pitchFamily="34" charset="-122"/>
                 <a:cs typeface="Calibri" pitchFamily="34" charset="-120"/>
               </a:rPr>
-              <a:t>El Sprint 1 cerró con 3 de 71 horas en Listo</a:t>
+              <a:t>El objetivo del Sprint 1 funciona, pero no en develop</a:t>
             </a:r>
           </a:p>
         </p:txBody>
@@ -12784,7 +12784,7 @@
         <p:spPr>
           <a:xfrm>
             <a:off x="457200" y="1234440"/>
-            <a:ext cx="3246120" cy="1600200"/>
+            <a:ext cx="3246120" cy="1783080"/>
           </a:xfrm>
           <a:prstGeom prst="roundRect">
             <a:avLst>
@@ -12817,8 +12817,8 @@
         </p:nvSpPr>
         <p:spPr>
           <a:xfrm>
-            <a:off x="640080" y="1298448"/>
-            <a:ext cx="2926080" cy="640080"/>
+            <a:off x="640080" y="1280160"/>
+            <a:ext cx="2926080" cy="566928"/>
           </a:xfrm>
           <a:prstGeom prst="rect">
             <a:avLst/>
@@ -12842,7 +12842,7 @@
                 <a:ea typeface="Calibri" pitchFamily="34" charset="-122"/>
                 <a:cs typeface="Calibri" pitchFamily="34" charset="-120"/>
               </a:rPr>
-              <a:t>4 %</a:t>
+              <a:t>8 PR</a:t>
             </a:r>
           </a:p>
         </p:txBody>
@@ -12855,8 +12855,8 @@
         </p:nvSpPr>
         <p:spPr>
           <a:xfrm>
-            <a:off x="640080" y="1938528"/>
-            <a:ext cx="2926080" cy="822960"/>
+            <a:off x="640080" y="1865376"/>
+            <a:ext cx="2926080" cy="1115568"/>
           </a:xfrm>
           <a:prstGeom prst="rect">
             <a:avLst/>
@@ -12872,7 +12872,7 @@
               <a:buNone/>
             </a:pPr>
             <a:r>
-              <a:rPr lang="en-US" sz="1400" dirty="0" b="1">
+              <a:rPr lang="en-US" sz="1300" dirty="0" b="1">
                 <a:solidFill>
                   <a:srgbClr val="1E2A3A"/>
                 </a:solidFill>
@@ -12883,7 +12883,7 @@
               <a:t>Sprint 1 (21-09 al 04-10): </a:t>
             </a:r>
             <a:r>
-              <a:rPr lang="en-US" sz="1400" dirty="0" b="0">
+              <a:rPr lang="en-US" sz="1300" dirty="0" b="0">
                 <a:solidFill>
                   <a:srgbClr val="1E2A3A"/>
                 </a:solidFill>
@@ -12891,7 +12891,37 @@
                 <a:ea typeface="Calibri" pitchFamily="34" charset="-122"/>
                 <a:cs typeface="Calibri" pitchFamily="34" charset="-120"/>
               </a:rPr>
-              <a:t>3 de 71 horas en Listo, porque los PR esperaban revisión.</a:t>
+              <a:t>integrados en demo/semana-08, donde el recorrido CA1 funciona desde el 02-10.</a:t>
+            </a:r>
+          </a:p>
+          <a:p>
+            <a:pPr marL="0" indent="0">
+              <a:spcBef>
+                <a:spcPts val="500"/>
+              </a:spcBef>
+              <a:buNone/>
+            </a:pPr>
+            <a:r>
+              <a:rPr lang="en-US" sz="1300" dirty="0" b="1">
+                <a:solidFill>
+                  <a:srgbClr val="1E2A3A"/>
+                </a:solidFill>
+                <a:latin typeface="Calibri" pitchFamily="34" charset="0"/>
+                <a:ea typeface="Calibri" pitchFamily="34" charset="-122"/>
+                <a:cs typeface="Calibri" pitchFamily="34" charset="-120"/>
+              </a:rPr>
+              <a:t>En Listo: </a:t>
+            </a:r>
+            <a:r>
+              <a:rPr lang="en-US" sz="1300" dirty="0" b="0">
+                <a:solidFill>
+                  <a:srgbClr val="1E2A3A"/>
+                </a:solidFill>
+                <a:latin typeface="Calibri" pitchFamily="34" charset="0"/>
+                <a:ea typeface="Calibri" pitchFamily="34" charset="-122"/>
+                <a:cs typeface="Calibri" pitchFamily="34" charset="-120"/>
+              </a:rPr>
+              <a:t>3 de 71 h (4 %). Al 16-10, solo el #7 está en develop.</a:t>
             </a:r>
           </a:p>
         </p:txBody>
@@ -12904,8 +12934,8 @@
         </p:nvSpPr>
         <p:spPr>
           <a:xfrm>
-            <a:off x="457200" y="2971800"/>
-            <a:ext cx="3246120" cy="1600200"/>
+            <a:off x="457200" y="3154680"/>
+            <a:ext cx="3246120" cy="1481328"/>
           </a:xfrm>
           <a:prstGeom prst="roundRect">
             <a:avLst>
@@ -12938,7 +12968,7 @@
         </p:nvSpPr>
         <p:spPr>
           <a:xfrm>
-            <a:off x="640080" y="3044952"/>
+            <a:off x="640080" y="3227832"/>
             <a:ext cx="2926080" cy="502920"/>
           </a:xfrm>
           <a:prstGeom prst="rect">
@@ -12976,8 +13006,8 @@
         </p:nvSpPr>
         <p:spPr>
           <a:xfrm>
-            <a:off x="640080" y="3584448"/>
-            <a:ext cx="2926080" cy="868680"/>
+            <a:off x="640080" y="3749039"/>
+            <a:ext cx="2926080" cy="822960"/>
           </a:xfrm>
           <a:prstGeom prst="rect">
             <a:avLst/>
@@ -13012,7 +13042,7 @@
                 <a:ea typeface="Calibri" pitchFamily="34" charset="-122"/>
                 <a:cs typeface="Calibri" pitchFamily="34" charset="-120"/>
               </a:rPr>
-              <a:t>revisión de los PR y fusión del #7. El contrato HU-03 sigue pendiente.</a:t>
+              <a:t>Damaris revisó y probó cuatro PR. Siguen pendientes otras revisiones y el contrato HU-03.</a:t>
             </a:r>
           </a:p>
         </p:txBody>

</xml_diff>